<commit_message>
docs: add a security and data-control slide to the overview deck
Separates the security posture from the agent-autonomy rails it used to
share a slide with: telemetry (none — DO_NOT_TRACK, HF and LiteLLM
telemetry off, local cost map, no analytics package in the lock), where
prompts and code actually go, data at rest, network exposure and the
token warning, outbound-knowledge redaction, tool egress and the scoped
TLS opt-outs, supply chain, and isolation — plus a plain statement of
the limit, that the chat agent has full shell on the host by default.

Co-Authored-By: Claude Opus 5 (1M context) <noreply@anthropic.com>
Claude-Session: https://claude.ai/code/session_01Uo5Ds1h5Xm4SBeHRuShj2j
</commit_message>
<xml_diff>
--- a/docs/AIForgeCrew-Overview.pptx
+++ b/docs/AIForgeCrew-Overview.pptx
@@ -24,6 +24,7 @@
     <p:sldId id="272" r:id="rId23"/>
     <p:sldId id="273" r:id="rId24"/>
     <p:sldId id="274" r:id="rId25"/>
+    <p:sldId id="275" r:id="rId26"/>
   </p:sldIdLst>
   <p:sldSz cx="12191695" cy="6858000" type="screen4x3"/>
   <p:notesSz cx="6858000" cy="9144000"/>
@@ -5102,6 +5103,680 @@
                 </a:solidFill>
                 <a:latin typeface="Calibri"/>
               </a:rPr>
+              <a:t>Security and data control</a:t>
+            </a:r>
+          </a:p>
+        </p:txBody>
+      </p:sp>
+      <p:sp>
+        <p:nvSpPr>
+          <p:cNvPr id="3" name="Rectangle 2"/>
+          <p:cNvSpPr/>
+          <p:nvPr/>
+        </p:nvSpPr>
+        <p:spPr>
+          <a:xfrm>
+            <a:off x="685800" y="1078992"/>
+            <a:ext cx="10817352" cy="17780"/>
+          </a:xfrm>
+          <a:prstGeom prst="rect">
+            <a:avLst/>
+          </a:prstGeom>
+          <a:solidFill>
+            <a:srgbClr val="1F4E79"/>
+          </a:solidFill>
+          <a:ln>
+            <a:noFill/>
+          </a:ln>
+          <a:effectLst/>
+        </p:spPr>
+        <p:style>
+          <a:lnRef idx="1">
+            <a:schemeClr val="accent1"/>
+          </a:lnRef>
+          <a:fillRef idx="3">
+            <a:schemeClr val="accent1"/>
+          </a:fillRef>
+          <a:effectRef idx="2">
+            <a:schemeClr val="accent1"/>
+          </a:effectRef>
+          <a:fontRef idx="minor">
+            <a:schemeClr val="lt1"/>
+          </a:fontRef>
+        </p:style>
+        <p:txBody>
+          <a:bodyPr rtlCol="0" anchor="ctr"/>
+          <a:lstStyle/>
+          <a:p>
+            <a:pPr algn="ctr"/>
+          </a:p>
+        </p:txBody>
+      </p:sp>
+      <p:sp>
+        <p:nvSpPr>
+          <p:cNvPr id="4" name="TextBox 3"/>
+          <p:cNvSpPr txBox="1"/>
+          <p:nvPr/>
+        </p:nvSpPr>
+        <p:spPr>
+          <a:xfrm>
+            <a:off x="685800" y="1188720"/>
+            <a:ext cx="10817352" cy="384048"/>
+          </a:xfrm>
+          <a:prstGeom prst="rect">
+            <a:avLst/>
+          </a:prstGeom>
+          <a:noFill/>
+        </p:spPr>
+        <p:txBody>
+          <a:bodyPr wrap="none">
+            <a:spAutoFit/>
+          </a:bodyPr>
+          <a:lstStyle/>
+          <a:p>
+            <a:r>
+              <a:rPr sz="1400" i="1">
+                <a:solidFill>
+                  <a:srgbClr val="666666"/>
+                </a:solidFill>
+                <a:latin typeface="Calibri"/>
+              </a:rPr>
+              <a:t>No telemetry. Nothing leaves the machine unless you point it somewhere.</a:t>
+            </a:r>
+          </a:p>
+        </p:txBody>
+      </p:sp>
+      <p:graphicFrame>
+        <p:nvGraphicFramePr>
+          <p:cNvPr id="5" name="Table 4"/>
+          <p:cNvGraphicFramePr>
+            <a:graphicFrameLocks noGrp="1"/>
+          </p:cNvGraphicFramePr>
+          <p:nvPr/>
+        </p:nvGraphicFramePr>
+        <p:xfrm>
+          <a:off x="685800" y="1664208"/>
+          <a:ext cx="10817352" cy="4114800"/>
+        </p:xfrm>
+        <a:graphic>
+          <a:graphicData uri="http://schemas.openxmlformats.org/drawingml/2006/table">
+            <a:tbl>
+              <a:tblPr firstRow="1" bandRow="1">
+                <a:tableStyleId>{5C22544A-7EE6-4342-B048-85BDC9FD1C3A}</a:tableStyleId>
+              </a:tblPr>
+              <a:tblGrid>
+                <a:gridCol w="1737360"/>
+                <a:gridCol w="9079992"/>
+              </a:tblGrid>
+              <a:tr h="457200">
+                <a:tc>
+                  <a:txBody>
+                    <a:bodyPr/>
+                    <a:lstStyle/>
+                    <a:p>
+                      <a:r>
+                        <a:rPr sz="1100" b="1">
+                          <a:solidFill>
+                            <a:srgbClr val="1F4E79"/>
+                          </a:solidFill>
+                          <a:latin typeface="Calibri"/>
+                        </a:rPr>
+                        <a:t>Concern</a:t>
+                      </a:r>
+                    </a:p>
+                  </a:txBody>
+                  <a:tcPr marL="64008" marT="27432" marB="27432">
+                    <a:solidFill>
+                      <a:srgbClr val="FFFFFF"/>
+                    </a:solidFill>
+                  </a:tcPr>
+                </a:tc>
+                <a:tc>
+                  <a:txBody>
+                    <a:bodyPr/>
+                    <a:lstStyle/>
+                    <a:p>
+                      <a:r>
+                        <a:rPr sz="1100" b="1">
+                          <a:solidFill>
+                            <a:srgbClr val="1F4E79"/>
+                          </a:solidFill>
+                          <a:latin typeface="Calibri"/>
+                        </a:rPr>
+                        <a:t>How it is handled</a:t>
+                      </a:r>
+                    </a:p>
+                  </a:txBody>
+                  <a:tcPr marL="64008" marT="27432" marB="27432">
+                    <a:solidFill>
+                      <a:srgbClr val="FFFFFF"/>
+                    </a:solidFill>
+                  </a:tcPr>
+                </a:tc>
+              </a:tr>
+              <a:tr h="457200">
+                <a:tc>
+                  <a:txBody>
+                    <a:bodyPr wrap="square"/>
+                    <a:lstStyle/>
+                    <a:p>
+                      <a:r>
+                        <a:rPr sz="1100" b="1">
+                          <a:solidFill>
+                            <a:srgbClr val="333333"/>
+                          </a:solidFill>
+                          <a:latin typeface="Calibri"/>
+                        </a:rPr>
+                        <a:t>Telemetry</a:t>
+                      </a:r>
+                    </a:p>
+                  </a:txBody>
+                  <a:tcPr marL="64008" marT="27432" marB="27432">
+                    <a:solidFill>
+                      <a:srgbClr val="FFFFFF"/>
+                    </a:solidFill>
+                  </a:tcPr>
+                </a:tc>
+                <a:tc>
+                  <a:txBody>
+                    <a:bodyPr wrap="square"/>
+                    <a:lstStyle/>
+                    <a:p>
+                      <a:r>
+                        <a:rPr sz="1100" b="0">
+                          <a:solidFill>
+                            <a:srgbClr val="333333"/>
+                          </a:solidFill>
+                          <a:latin typeface="Calibri"/>
+                        </a:rPr>
+                        <a:t>None. DO_NOT_TRACK=1, Hugging Face and LiteLLM telemetry off, cost map read locally — and no analytics package in the 599-package lock</a:t>
+                      </a:r>
+                    </a:p>
+                  </a:txBody>
+                  <a:tcPr marL="64008" marT="27432" marB="27432">
+                    <a:solidFill>
+                      <a:srgbClr val="FFFFFF"/>
+                    </a:solidFill>
+                  </a:tcPr>
+                </a:tc>
+              </a:tr>
+              <a:tr h="457200">
+                <a:tc>
+                  <a:txBody>
+                    <a:bodyPr wrap="square"/>
+                    <a:lstStyle/>
+                    <a:p>
+                      <a:r>
+                        <a:rPr sz="1100" b="1">
+                          <a:solidFill>
+                            <a:srgbClr val="333333"/>
+                          </a:solidFill>
+                          <a:latin typeface="Calibri"/>
+                        </a:rPr>
+                        <a:t>Prompts and code</a:t>
+                      </a:r>
+                    </a:p>
+                  </a:txBody>
+                  <a:tcPr marL="64008" marT="27432" marB="27432">
+                    <a:solidFill>
+                      <a:srgbClr val="F7F7F7"/>
+                    </a:solidFill>
+                  </a:tcPr>
+                </a:tc>
+                <a:tc>
+                  <a:txBody>
+                    <a:bodyPr wrap="square"/>
+                    <a:lstStyle/>
+                    <a:p>
+                      <a:r>
+                        <a:rPr sz="1100" b="0">
+                          <a:solidFill>
+                            <a:srgbClr val="333333"/>
+                          </a:solidFill>
+                          <a:latin typeface="Calibri"/>
+                        </a:rPr>
+                        <a:t>Go only to the endpoint you configure. Point it at LM Studio, vLLM or mlx on your own hardware and nothing leaves the box</a:t>
+                      </a:r>
+                    </a:p>
+                  </a:txBody>
+                  <a:tcPr marL="64008" marT="27432" marB="27432">
+                    <a:solidFill>
+                      <a:srgbClr val="F7F7F7"/>
+                    </a:solidFill>
+                  </a:tcPr>
+                </a:tc>
+              </a:tr>
+              <a:tr h="457200">
+                <a:tc>
+                  <a:txBody>
+                    <a:bodyPr wrap="square"/>
+                    <a:lstStyle/>
+                    <a:p>
+                      <a:r>
+                        <a:rPr sz="1100" b="1">
+                          <a:solidFill>
+                            <a:srgbClr val="333333"/>
+                          </a:solidFill>
+                          <a:latin typeface="Calibri"/>
+                        </a:rPr>
+                        <a:t>Data at rest</a:t>
+                      </a:r>
+                    </a:p>
+                  </a:txBody>
+                  <a:tcPr marL="64008" marT="27432" marB="27432">
+                    <a:solidFill>
+                      <a:srgbClr val="FFFFFF"/>
+                    </a:solidFill>
+                  </a:tcPr>
+                </a:tc>
+                <a:tc>
+                  <a:txBody>
+                    <a:bodyPr wrap="square"/>
+                    <a:lstStyle/>
+                    <a:p>
+                      <a:r>
+                        <a:rPr sz="1100" b="0">
+                          <a:solidFill>
+                            <a:srgbClr val="333333"/>
+                          </a:solidFill>
+                          <a:latin typeface="Calibri"/>
+                        </a:rPr>
+                        <a:t>~/.aiforge/ — markdown files and one SQLite file. Delete the folder and the memory is gone; there is no second copy</a:t>
+                      </a:r>
+                    </a:p>
+                  </a:txBody>
+                  <a:tcPr marL="64008" marT="27432" marB="27432">
+                    <a:solidFill>
+                      <a:srgbClr val="FFFFFF"/>
+                    </a:solidFill>
+                  </a:tcPr>
+                </a:tc>
+              </a:tr>
+              <a:tr h="457200">
+                <a:tc>
+                  <a:txBody>
+                    <a:bodyPr wrap="square"/>
+                    <a:lstStyle/>
+                    <a:p>
+                      <a:r>
+                        <a:rPr sz="1100" b="1">
+                          <a:solidFill>
+                            <a:srgbClr val="333333"/>
+                          </a:solidFill>
+                          <a:latin typeface="Calibri"/>
+                        </a:rPr>
+                        <a:t>Network exposure</a:t>
+                      </a:r>
+                    </a:p>
+                  </a:txBody>
+                  <a:tcPr marL="64008" marT="27432" marB="27432">
+                    <a:solidFill>
+                      <a:srgbClr val="F7F7F7"/>
+                    </a:solidFill>
+                  </a:tcPr>
+                </a:tc>
+                <a:tc>
+                  <a:txBody>
+                    <a:bodyPr wrap="square"/>
+                    <a:lstStyle/>
+                    <a:p>
+                      <a:r>
+                        <a:rPr sz="1100" b="0">
+                          <a:solidFill>
+                            <a:srgbClr val="333333"/>
+                          </a:solidFill>
+                          <a:latin typeface="Calibri"/>
+                        </a:rPr>
+                        <a:t>Loopback by default, and a loud warning if bound off-loopback with no AIFORGE_API_TOKEN. Fleet sync is open for LAN or WireGuard; one flag closes it</a:t>
+                      </a:r>
+                    </a:p>
+                  </a:txBody>
+                  <a:tcPr marL="64008" marT="27432" marB="27432">
+                    <a:solidFill>
+                      <a:srgbClr val="F7F7F7"/>
+                    </a:solidFill>
+                  </a:tcPr>
+                </a:tc>
+              </a:tr>
+              <a:tr h="457200">
+                <a:tc>
+                  <a:txBody>
+                    <a:bodyPr wrap="square"/>
+                    <a:lstStyle/>
+                    <a:p>
+                      <a:r>
+                        <a:rPr sz="1100" b="1">
+                          <a:solidFill>
+                            <a:srgbClr val="333333"/>
+                          </a:solidFill>
+                          <a:latin typeface="Calibri"/>
+                        </a:rPr>
+                        <a:t>Outbound knowledge</a:t>
+                      </a:r>
+                    </a:p>
+                  </a:txBody>
+                  <a:tcPr marL="64008" marT="27432" marB="27432">
+                    <a:solidFill>
+                      <a:srgbClr val="FFFFFF"/>
+                    </a:solidFill>
+                  </a:tcPr>
+                </a:tc>
+                <a:tc>
+                  <a:txBody>
+                    <a:bodyPr wrap="square"/>
+                    <a:lstStyle/>
+                    <a:p>
+                      <a:r>
+                        <a:rPr sz="1100" b="0">
+                          <a:solidFill>
+                            <a:srgbClr val="333333"/>
+                          </a:solidFill>
+                          <a:latin typeface="Calibri"/>
+                        </a:rPr>
+                        <a:t>A secrets / private / noise filter runs on the client before a note is advertised; a blocked note is dropped whole, never edited</a:t>
+                      </a:r>
+                    </a:p>
+                  </a:txBody>
+                  <a:tcPr marL="64008" marT="27432" marB="27432">
+                    <a:solidFill>
+                      <a:srgbClr val="FFFFFF"/>
+                    </a:solidFill>
+                  </a:tcPr>
+                </a:tc>
+              </a:tr>
+              <a:tr h="457200">
+                <a:tc>
+                  <a:txBody>
+                    <a:bodyPr wrap="square"/>
+                    <a:lstStyle/>
+                    <a:p>
+                      <a:r>
+                        <a:rPr sz="1100" b="1">
+                          <a:solidFill>
+                            <a:srgbClr val="333333"/>
+                          </a:solidFill>
+                          <a:latin typeface="Calibri"/>
+                        </a:rPr>
+                        <a:t>Tool egress</a:t>
+                      </a:r>
+                    </a:p>
+                  </a:txBody>
+                  <a:tcPr marL="64008" marT="27432" marB="27432">
+                    <a:solidFill>
+                      <a:srgbClr val="F7F7F7"/>
+                    </a:solidFill>
+                  </a:tcPr>
+                </a:tc>
+                <a:tc>
+                  <a:txBody>
+                    <a:bodyPr wrap="square"/>
+                    <a:lstStyle/>
+                    <a:p>
+                      <a:r>
+                        <a:rPr sz="1100" b="0">
+                          <a:solidFill>
+                            <a:srgbClr val="333333"/>
+                          </a:solidFill>
+                          <a:latin typeface="Calibri"/>
+                        </a:rPr>
+                        <a:t>SSRF guard on web fetch and crawl. TLS verification is disabled only per endpoint, opt-in, for self-signed internal hosts</a:t>
+                      </a:r>
+                    </a:p>
+                  </a:txBody>
+                  <a:tcPr marL="64008" marT="27432" marB="27432">
+                    <a:solidFill>
+                      <a:srgbClr val="F7F7F7"/>
+                    </a:solidFill>
+                  </a:tcPr>
+                </a:tc>
+              </a:tr>
+              <a:tr h="457200">
+                <a:tc>
+                  <a:txBody>
+                    <a:bodyPr wrap="square"/>
+                    <a:lstStyle/>
+                    <a:p>
+                      <a:r>
+                        <a:rPr sz="1100" b="1">
+                          <a:solidFill>
+                            <a:srgbClr val="333333"/>
+                          </a:solidFill>
+                          <a:latin typeface="Calibri"/>
+                        </a:rPr>
+                        <a:t>Supply chain</a:t>
+                      </a:r>
+                    </a:p>
+                  </a:txBody>
+                  <a:tcPr marL="64008" marT="27432" marB="27432">
+                    <a:solidFill>
+                      <a:srgbClr val="FFFFFF"/>
+                    </a:solidFill>
+                  </a:tcPr>
+                </a:tc>
+                <a:tc>
+                  <a:txBody>
+                    <a:bodyPr wrap="square"/>
+                    <a:lstStyle/>
+                    <a:p>
+                      <a:r>
+                        <a:rPr sz="1100" b="0">
+                          <a:solidFill>
+                            <a:srgbClr val="333333"/>
+                          </a:solidFill>
+                          <a:latin typeface="Calibri"/>
+                        </a:rPr>
+                        <a:t>uv.lock pinned and shipped; Trivy clean; CI emits a CycloneDX SBOM and pinned requirements for Black Duck; Sonar reports 0 bugs</a:t>
+                      </a:r>
+                    </a:p>
+                  </a:txBody>
+                  <a:tcPr marL="64008" marT="27432" marB="27432">
+                    <a:solidFill>
+                      <a:srgbClr val="FFFFFF"/>
+                    </a:solidFill>
+                  </a:tcPr>
+                </a:tc>
+              </a:tr>
+              <a:tr h="457200">
+                <a:tc>
+                  <a:txBody>
+                    <a:bodyPr wrap="square"/>
+                    <a:lstStyle/>
+                    <a:p>
+                      <a:r>
+                        <a:rPr sz="1100" b="1">
+                          <a:solidFill>
+                            <a:srgbClr val="333333"/>
+                          </a:solidFill>
+                          <a:latin typeface="Calibri"/>
+                        </a:rPr>
+                        <a:t>Isolation</a:t>
+                      </a:r>
+                    </a:p>
+                  </a:txBody>
+                  <a:tcPr marL="64008" marT="27432" marB="27432">
+                    <a:solidFill>
+                      <a:srgbClr val="F7F7F7"/>
+                    </a:solidFill>
+                  </a:tcPr>
+                </a:tc>
+                <a:tc>
+                  <a:txBody>
+                    <a:bodyPr wrap="square"/>
+                    <a:lstStyle/>
+                    <a:p>
+                      <a:r>
+                        <a:rPr sz="1100" b="0">
+                          <a:solidFill>
+                            <a:srgbClr val="333333"/>
+                          </a:solidFill>
+                          <a:latin typeface="Calibri"/>
+                        </a:rPr>
+                        <a:t>AIFORGE_WORKSPACE_DIR clamps file and exec to one directory; the workspace jail is on by default; container mode for untrusted use</a:t>
+                      </a:r>
+                    </a:p>
+                  </a:txBody>
+                  <a:tcPr marL="64008" marT="27432" marB="27432">
+                    <a:solidFill>
+                      <a:srgbClr val="F7F7F7"/>
+                    </a:solidFill>
+                  </a:tcPr>
+                </a:tc>
+              </a:tr>
+            </a:tbl>
+          </a:graphicData>
+        </a:graphic>
+      </p:graphicFrame>
+      <p:sp>
+        <p:nvSpPr>
+          <p:cNvPr id="6" name="TextBox 5"/>
+          <p:cNvSpPr txBox="1"/>
+          <p:nvPr/>
+        </p:nvSpPr>
+        <p:spPr>
+          <a:xfrm>
+            <a:off x="685800" y="5532120"/>
+            <a:ext cx="10817352" cy="457200"/>
+          </a:xfrm>
+          <a:prstGeom prst="rect">
+            <a:avLst/>
+          </a:prstGeom>
+          <a:noFill/>
+        </p:spPr>
+        <p:txBody>
+          <a:bodyPr wrap="square">
+            <a:spAutoFit/>
+          </a:bodyPr>
+          <a:lstStyle/>
+          <a:p>
+            <a:pPr algn="l"/>
+            <a:r>
+              <a:rPr sz="1100" i="1">
+                <a:solidFill>
+                  <a:srgbClr val="666666"/>
+                </a:solidFill>
+                <a:latin typeface="Calibri"/>
+              </a:rPr>
+              <a:t>Stated plainly: by default the chat agent has full, unsandboxed shell access on the host. The jail guards file tools, not arbitrary shell — treat the chat box like a terminal, and run untrusted work in the container mode.</a:t>
+            </a:r>
+          </a:p>
+        </p:txBody>
+      </p:sp>
+      <p:sp>
+        <p:nvSpPr>
+          <p:cNvPr id="7" name="TextBox 6"/>
+          <p:cNvSpPr txBox="1"/>
+          <p:nvPr/>
+        </p:nvSpPr>
+        <p:spPr>
+          <a:xfrm>
+            <a:off x="11064240" y="6355080"/>
+            <a:ext cx="822960" cy="320040"/>
+          </a:xfrm>
+          <a:prstGeom prst="rect">
+            <a:avLst/>
+          </a:prstGeom>
+          <a:noFill/>
+        </p:spPr>
+        <p:txBody>
+          <a:bodyPr wrap="none">
+            <a:spAutoFit/>
+          </a:bodyPr>
+          <a:lstStyle/>
+          <a:p>
+            <a:pPr algn="r"/>
+            <a:r>
+              <a:rPr sz="1000">
+                <a:solidFill>
+                  <a:srgbClr val="666666"/>
+                </a:solidFill>
+                <a:latin typeface="Calibri"/>
+              </a:rPr>
+              <a:t>14</a:t>
+            </a:r>
+          </a:p>
+        </p:txBody>
+      </p:sp>
+      <p:sp>
+        <p:nvSpPr>
+          <p:cNvPr id="8" name="TextBox 7"/>
+          <p:cNvSpPr txBox="1"/>
+          <p:nvPr/>
+        </p:nvSpPr>
+        <p:spPr>
+          <a:xfrm>
+            <a:off x="685800" y="6355080"/>
+            <a:ext cx="5486400" cy="320040"/>
+          </a:xfrm>
+          <a:prstGeom prst="rect">
+            <a:avLst/>
+          </a:prstGeom>
+          <a:noFill/>
+        </p:spPr>
+        <p:txBody>
+          <a:bodyPr wrap="none">
+            <a:spAutoFit/>
+          </a:bodyPr>
+          <a:lstStyle/>
+          <a:p>
+            <a:r>
+              <a:rPr sz="1000">
+                <a:solidFill>
+                  <a:srgbClr val="666666"/>
+                </a:solidFill>
+                <a:latin typeface="Calibri"/>
+              </a:rPr>
+              <a:t>AIForgeCrew</a:t>
+            </a:r>
+          </a:p>
+        </p:txBody>
+      </p:sp>
+    </p:spTree>
+  </p:cSld>
+  <p:clrMapOvr>
+    <a:masterClrMapping/>
+  </p:clrMapOvr>
+</p:sld>
+</file>
+
+<file path=ppt/slides/slide15.xml><?xml version="1.0" encoding="utf-8"?>
+<p:sld xmlns:a="http://schemas.openxmlformats.org/drawingml/2006/main" xmlns:p="http://schemas.openxmlformats.org/presentationml/2006/main" xmlns:r="http://schemas.openxmlformats.org/officeDocument/2006/relationships">
+  <p:cSld>
+    <p:spTree>
+      <p:nvGrpSpPr>
+        <p:cNvPr id="1" name=""/>
+        <p:cNvGrpSpPr/>
+        <p:nvPr/>
+      </p:nvGrpSpPr>
+      <p:grpSpPr/>
+      <p:sp>
+        <p:nvSpPr>
+          <p:cNvPr id="2" name="TextBox 1"/>
+          <p:cNvSpPr txBox="1"/>
+          <p:nvPr/>
+        </p:nvSpPr>
+        <p:spPr>
+          <a:xfrm>
+            <a:off x="685800" y="411480"/>
+            <a:ext cx="10817352" cy="640080"/>
+          </a:xfrm>
+          <a:prstGeom prst="rect">
+            <a:avLst/>
+          </a:prstGeom>
+          <a:noFill/>
+        </p:spPr>
+        <p:txBody>
+          <a:bodyPr wrap="none">
+            <a:spAutoFit/>
+          </a:bodyPr>
+          <a:lstStyle/>
+          <a:p>
+            <a:r>
+              <a:rPr sz="3000" b="1">
+                <a:solidFill>
+                  <a:srgbClr val="111111"/>
+                </a:solidFill>
+                <a:latin typeface="Calibri"/>
+              </a:rPr>
               <a:t>Groups and fleet memory sync</a:t>
             </a:r>
           </a:p>
@@ -5749,7 +6424,7 @@
                 </a:solidFill>
                 <a:latin typeface="Calibri"/>
               </a:rPr>
-              <a:t>14</a:t>
+              <a:t>15</a:t>
             </a:r>
           </a:p>
         </p:txBody>
@@ -5796,7 +6471,7 @@
 </p:sld>
 </file>
 
-<file path=ppt/slides/slide15.xml><?xml version="1.0" encoding="utf-8"?>
+<file path=ppt/slides/slide16.xml><?xml version="1.0" encoding="utf-8"?>
 <p:sld xmlns:a="http://schemas.openxmlformats.org/drawingml/2006/main" xmlns:p="http://schemas.openxmlformats.org/presentationml/2006/main" xmlns:r="http://schemas.openxmlformats.org/officeDocument/2006/relationships">
   <p:cSld>
     <p:spTree>
@@ -6486,7 +7161,7 @@
                 </a:solidFill>
                 <a:latin typeface="Calibri"/>
               </a:rPr>
-              <a:t>15</a:t>
+              <a:t>16</a:t>
             </a:r>
           </a:p>
         </p:txBody>
@@ -6533,7 +7208,7 @@
 </p:sld>
 </file>
 
-<file path=ppt/slides/slide16.xml><?xml version="1.0" encoding="utf-8"?>
+<file path=ppt/slides/slide17.xml><?xml version="1.0" encoding="utf-8"?>
 <p:sld xmlns:a="http://schemas.openxmlformats.org/drawingml/2006/main" xmlns:p="http://schemas.openxmlformats.org/presentationml/2006/main" xmlns:r="http://schemas.openxmlformats.org/officeDocument/2006/relationships">
   <p:cSld>
     <p:spTree>
@@ -7256,7 +7931,7 @@
                 </a:solidFill>
                 <a:latin typeface="Calibri"/>
               </a:rPr>
-              <a:t>16</a:t>
+              <a:t>17</a:t>
             </a:r>
           </a:p>
         </p:txBody>
@@ -7303,7 +7978,7 @@
 </p:sld>
 </file>
 
-<file path=ppt/slides/slide17.xml><?xml version="1.0" encoding="utf-8"?>
+<file path=ppt/slides/slide18.xml><?xml version="1.0" encoding="utf-8"?>
 <p:sld xmlns:a="http://schemas.openxmlformats.org/drawingml/2006/main" xmlns:p="http://schemas.openxmlformats.org/presentationml/2006/main" xmlns:r="http://schemas.openxmlformats.org/officeDocument/2006/relationships">
   <p:cSld>
     <p:spTree>
@@ -7988,7 +8663,7 @@
                 </a:solidFill>
                 <a:latin typeface="Calibri"/>
               </a:rPr>
-              <a:t>17</a:t>
+              <a:t>18</a:t>
             </a:r>
           </a:p>
         </p:txBody>
@@ -7996,378 +8671,6 @@
       <p:sp>
         <p:nvSpPr>
           <p:cNvPr id="8" name="TextBox 7"/>
-          <p:cNvSpPr txBox="1"/>
-          <p:nvPr/>
-        </p:nvSpPr>
-        <p:spPr>
-          <a:xfrm>
-            <a:off x="685800" y="6355080"/>
-            <a:ext cx="5486400" cy="320040"/>
-          </a:xfrm>
-          <a:prstGeom prst="rect">
-            <a:avLst/>
-          </a:prstGeom>
-          <a:noFill/>
-        </p:spPr>
-        <p:txBody>
-          <a:bodyPr wrap="none">
-            <a:spAutoFit/>
-          </a:bodyPr>
-          <a:lstStyle/>
-          <a:p>
-            <a:r>
-              <a:rPr sz="1000">
-                <a:solidFill>
-                  <a:srgbClr val="666666"/>
-                </a:solidFill>
-                <a:latin typeface="Calibri"/>
-              </a:rPr>
-              <a:t>AIForgeCrew</a:t>
-            </a:r>
-          </a:p>
-        </p:txBody>
-      </p:sp>
-    </p:spTree>
-  </p:cSld>
-  <p:clrMapOvr>
-    <a:masterClrMapping/>
-  </p:clrMapOvr>
-</p:sld>
-</file>
-
-<file path=ppt/slides/slide18.xml><?xml version="1.0" encoding="utf-8"?>
-<p:sld xmlns:a="http://schemas.openxmlformats.org/drawingml/2006/main" xmlns:p="http://schemas.openxmlformats.org/presentationml/2006/main" xmlns:r="http://schemas.openxmlformats.org/officeDocument/2006/relationships">
-  <p:cSld>
-    <p:spTree>
-      <p:nvGrpSpPr>
-        <p:cNvPr id="1" name=""/>
-        <p:cNvGrpSpPr/>
-        <p:nvPr/>
-      </p:nvGrpSpPr>
-      <p:grpSpPr/>
-      <p:sp>
-        <p:nvSpPr>
-          <p:cNvPr id="2" name="TextBox 1"/>
-          <p:cNvSpPr txBox="1"/>
-          <p:nvPr/>
-        </p:nvSpPr>
-        <p:spPr>
-          <a:xfrm>
-            <a:off x="685800" y="411480"/>
-            <a:ext cx="10817352" cy="640080"/>
-          </a:xfrm>
-          <a:prstGeom prst="rect">
-            <a:avLst/>
-          </a:prstGeom>
-          <a:noFill/>
-        </p:spPr>
-        <p:txBody>
-          <a:bodyPr wrap="none">
-            <a:spAutoFit/>
-          </a:bodyPr>
-          <a:lstStyle/>
-          <a:p>
-            <a:r>
-              <a:rPr sz="3000" b="1">
-                <a:solidFill>
-                  <a:srgbClr val="111111"/>
-                </a:solidFill>
-                <a:latin typeface="Calibri"/>
-              </a:rPr>
-              <a:t>How it is kept honest</a:t>
-            </a:r>
-          </a:p>
-        </p:txBody>
-      </p:sp>
-      <p:sp>
-        <p:nvSpPr>
-          <p:cNvPr id="3" name="Rectangle 2"/>
-          <p:cNvSpPr/>
-          <p:nvPr/>
-        </p:nvSpPr>
-        <p:spPr>
-          <a:xfrm>
-            <a:off x="685800" y="1078992"/>
-            <a:ext cx="10817352" cy="17780"/>
-          </a:xfrm>
-          <a:prstGeom prst="rect">
-            <a:avLst/>
-          </a:prstGeom>
-          <a:solidFill>
-            <a:srgbClr val="1F4E79"/>
-          </a:solidFill>
-          <a:ln>
-            <a:noFill/>
-          </a:ln>
-          <a:effectLst/>
-        </p:spPr>
-        <p:style>
-          <a:lnRef idx="1">
-            <a:schemeClr val="accent1"/>
-          </a:lnRef>
-          <a:fillRef idx="3">
-            <a:schemeClr val="accent1"/>
-          </a:fillRef>
-          <a:effectRef idx="2">
-            <a:schemeClr val="accent1"/>
-          </a:effectRef>
-          <a:fontRef idx="minor">
-            <a:schemeClr val="lt1"/>
-          </a:fontRef>
-        </p:style>
-        <p:txBody>
-          <a:bodyPr rtlCol="0" anchor="ctr"/>
-          <a:lstStyle/>
-          <a:p>
-            <a:pPr algn="ctr"/>
-          </a:p>
-        </p:txBody>
-      </p:sp>
-      <p:sp>
-        <p:nvSpPr>
-          <p:cNvPr id="4" name="TextBox 3"/>
-          <p:cNvSpPr txBox="1"/>
-          <p:nvPr/>
-        </p:nvSpPr>
-        <p:spPr>
-          <a:xfrm>
-            <a:off x="685800" y="1188720"/>
-            <a:ext cx="10817352" cy="384048"/>
-          </a:xfrm>
-          <a:prstGeom prst="rect">
-            <a:avLst/>
-          </a:prstGeom>
-          <a:noFill/>
-        </p:spPr>
-        <p:txBody>
-          <a:bodyPr wrap="none">
-            <a:spAutoFit/>
-          </a:bodyPr>
-          <a:lstStyle/>
-          <a:p>
-            <a:r>
-              <a:rPr sz="1400" i="1">
-                <a:solidFill>
-                  <a:srgbClr val="666666"/>
-                </a:solidFill>
-                <a:latin typeface="Calibri"/>
-              </a:rPr>
-              <a:t>Nothing here is claimed without a way to re-check it.</a:t>
-            </a:r>
-          </a:p>
-        </p:txBody>
-      </p:sp>
-      <p:sp>
-        <p:nvSpPr>
-          <p:cNvPr id="5" name="TextBox 4"/>
-          <p:cNvSpPr txBox="1"/>
-          <p:nvPr/>
-        </p:nvSpPr>
-        <p:spPr>
-          <a:xfrm>
-            <a:off x="685800" y="1664208"/>
-            <a:ext cx="10817352" cy="4754880"/>
-          </a:xfrm>
-          <a:prstGeom prst="rect">
-            <a:avLst/>
-          </a:prstGeom>
-          <a:noFill/>
-        </p:spPr>
-        <p:txBody>
-          <a:bodyPr wrap="square">
-            <a:spAutoFit/>
-          </a:bodyPr>
-          <a:lstStyle/>
-          <a:p>
-            <a:pPr>
-              <a:spcAft>
-                <a:spcPts val="800"/>
-              </a:spcAft>
-            </a:pPr>
-            <a:r>
-              <a:rPr b="1" sz="1600">
-                <a:solidFill>
-                  <a:srgbClr val="111111"/>
-                </a:solidFill>
-                <a:latin typeface="Calibri"/>
-              </a:rPr>
-              <a:t>•  ~4,000 tests on main, zero failing</a:t>
-            </a:r>
-            <a:r>
-              <a:rPr sz="1600">
-                <a:solidFill>
-                  <a:srgbClr val="333333"/>
-                </a:solidFill>
-                <a:latin typeface="Calibri"/>
-              </a:rPr>
-              <a:t> — and a fresh-environment reproduction in one command (`make test-docker`) so "works on my machine" is testable.</a:t>
-            </a:r>
-          </a:p>
-          <a:p>
-            <a:pPr>
-              <a:spcAft>
-                <a:spcPts val="800"/>
-              </a:spcAft>
-            </a:pPr>
-            <a:r>
-              <a:rPr b="1" sz="1600">
-                <a:solidFill>
-                  <a:srgbClr val="111111"/>
-                </a:solidFill>
-                <a:latin typeface="Calibri"/>
-              </a:rPr>
-              <a:t>•  Every fix is mutation-pinned</a:t>
-            </a:r>
-            <a:r>
-              <a:rPr sz="1600">
-                <a:solidFill>
-                  <a:srgbClr val="333333"/>
-                </a:solidFill>
-                <a:latin typeface="Calibri"/>
-              </a:rPr>
-              <a:t> — revert the fix and a named test must go red. Sweeps have found fixes that were pinned by nothing.</a:t>
-            </a:r>
-          </a:p>
-          <a:p>
-            <a:pPr>
-              <a:spcAft>
-                <a:spcPts val="800"/>
-              </a:spcAft>
-            </a:pPr>
-            <a:r>
-              <a:rPr b="1" sz="1600">
-                <a:solidFill>
-                  <a:srgbClr val="111111"/>
-                </a:solidFill>
-                <a:latin typeface="Calibri"/>
-              </a:rPr>
-              <a:t>•  New tests are run against the unfixed tree first</a:t>
-            </a:r>
-            <a:r>
-              <a:rPr sz="1600">
-                <a:solidFill>
-                  <a:srgbClr val="333333"/>
-                </a:solidFill>
-                <a:latin typeface="Calibri"/>
-              </a:rPr>
-              <a:t> — a test that passes before the fix proves nothing.</a:t>
-            </a:r>
-          </a:p>
-          <a:p>
-            <a:pPr>
-              <a:spcAft>
-                <a:spcPts val="800"/>
-              </a:spcAft>
-            </a:pPr>
-            <a:r>
-              <a:rPr b="1" sz="1600">
-                <a:solidFill>
-                  <a:srgbClr val="111111"/>
-                </a:solidFill>
-                <a:latin typeface="Calibri"/>
-              </a:rPr>
-              <a:t>•  Real static analysis, not a hand-rolled meter</a:t>
-            </a:r>
-            <a:r>
-              <a:rPr sz="1600">
-                <a:solidFill>
-                  <a:srgbClr val="333333"/>
-                </a:solidFill>
-                <a:latin typeface="Calibri"/>
-              </a:rPr>
-              <a:t> — SonarQube is ground truth; a local complexity counter under-read one function by 38 points.</a:t>
-            </a:r>
-          </a:p>
-          <a:p>
-            <a:pPr>
-              <a:spcAft>
-                <a:spcPts val="800"/>
-              </a:spcAft>
-            </a:pPr>
-            <a:r>
-              <a:rPr b="1" sz="1600">
-                <a:solidFill>
-                  <a:srgbClr val="111111"/>
-                </a:solidFill>
-                <a:latin typeface="Calibri"/>
-              </a:rPr>
-              <a:t>•  Review rounds are repeated until they find nothing</a:t>
-            </a:r>
-            <a:r>
-              <a:rPr sz="1600">
-                <a:solidFill>
-                  <a:srgbClr val="333333"/>
-                </a:solidFill>
-                <a:latin typeface="Calibri"/>
-              </a:rPr>
-              <a:t> — on several features every round found real defects inside the previous round's fixes.</a:t>
-            </a:r>
-          </a:p>
-          <a:p>
-            <a:pPr>
-              <a:spcAft>
-                <a:spcPts val="800"/>
-              </a:spcAft>
-            </a:pPr>
-            <a:r>
-              <a:rPr b="1" sz="1600">
-                <a:solidFill>
-                  <a:srgbClr val="111111"/>
-                </a:solidFill>
-                <a:latin typeface="Calibri"/>
-              </a:rPr>
-              <a:t>•  CI emits its own scan inputs</a:t>
-            </a:r>
-            <a:r>
-              <a:rPr sz="1600">
-                <a:solidFill>
-                  <a:srgbClr val="333333"/>
-                </a:solidFill>
-                <a:latin typeface="Calibri"/>
-              </a:rPr>
-              <a:t> — one build stage produces coverage, JUnit, pinned requirements and an SBOM for Sonar and Black Duck.</a:t>
-            </a:r>
-          </a:p>
-        </p:txBody>
-      </p:sp>
-      <p:sp>
-        <p:nvSpPr>
-          <p:cNvPr id="6" name="TextBox 5"/>
-          <p:cNvSpPr txBox="1"/>
-          <p:nvPr/>
-        </p:nvSpPr>
-        <p:spPr>
-          <a:xfrm>
-            <a:off x="11064240" y="6355080"/>
-            <a:ext cx="822960" cy="320040"/>
-          </a:xfrm>
-          <a:prstGeom prst="rect">
-            <a:avLst/>
-          </a:prstGeom>
-          <a:noFill/>
-        </p:spPr>
-        <p:txBody>
-          <a:bodyPr wrap="none">
-            <a:spAutoFit/>
-          </a:bodyPr>
-          <a:lstStyle/>
-          <a:p>
-            <a:pPr algn="r"/>
-            <a:r>
-              <a:rPr sz="1000">
-                <a:solidFill>
-                  <a:srgbClr val="666666"/>
-                </a:solidFill>
-                <a:latin typeface="Calibri"/>
-              </a:rPr>
-              <a:t>18</a:t>
-            </a:r>
-          </a:p>
-        </p:txBody>
-      </p:sp>
-      <p:sp>
-        <p:nvSpPr>
-          <p:cNvPr id="7" name="TextBox 6"/>
           <p:cNvSpPr txBox="1"/>
           <p:nvPr/>
         </p:nvSpPr>
@@ -8446,7 +8749,7 @@
                 </a:solidFill>
                 <a:latin typeface="Calibri"/>
               </a:rPr>
-              <a:t>In one slide</a:t>
+              <a:t>How it is kept honest</a:t>
             </a:r>
           </a:p>
         </p:txBody>
@@ -8503,7 +8806,41 @@
         </p:nvSpPr>
         <p:spPr>
           <a:xfrm>
-            <a:off x="685800" y="1298448"/>
+            <a:off x="685800" y="1188720"/>
+            <a:ext cx="10817352" cy="384048"/>
+          </a:xfrm>
+          <a:prstGeom prst="rect">
+            <a:avLst/>
+          </a:prstGeom>
+          <a:noFill/>
+        </p:spPr>
+        <p:txBody>
+          <a:bodyPr wrap="none">
+            <a:spAutoFit/>
+          </a:bodyPr>
+          <a:lstStyle/>
+          <a:p>
+            <a:r>
+              <a:rPr sz="1400" i="1">
+                <a:solidFill>
+                  <a:srgbClr val="666666"/>
+                </a:solidFill>
+                <a:latin typeface="Calibri"/>
+              </a:rPr>
+              <a:t>Nothing here is claimed without a way to re-check it.</a:t>
+            </a:r>
+          </a:p>
+        </p:txBody>
+      </p:sp>
+      <p:sp>
+        <p:nvSpPr>
+          <p:cNvPr id="5" name="TextBox 4"/>
+          <p:cNvSpPr txBox="1"/>
+          <p:nvPr/>
+        </p:nvSpPr>
+        <p:spPr>
+          <a:xfrm>
+            <a:off x="685800" y="1664208"/>
             <a:ext cx="10817352" cy="4754880"/>
           </a:xfrm>
           <a:prstGeom prst="rect">
@@ -8519,172 +8856,158 @@
           <a:p>
             <a:pPr>
               <a:spcAft>
-                <a:spcPts val="1300"/>
+                <a:spcPts val="800"/>
               </a:spcAft>
             </a:pPr>
             <a:r>
-              <a:rPr b="1" sz="1700">
+              <a:rPr b="1" sz="1600">
                 <a:solidFill>
                   <a:srgbClr val="111111"/>
                 </a:solidFill>
                 <a:latin typeface="Calibri"/>
               </a:rPr>
-              <a:t>•  Built as one FastAPI process</a:t>
-            </a:r>
-            <a:r>
-              <a:rPr sz="1700">
+              <a:t>•  ~4,000 tests on main, zero failing</a:t>
+            </a:r>
+            <a:r>
+              <a:rPr sz="1600">
                 <a:solidFill>
                   <a:srgbClr val="333333"/>
                 </a:solidFill>
                 <a:latin typeface="Calibri"/>
               </a:rPr>
-              <a:t> — no database to operate, no vendor lock, any OpenAI-compatible model.</a:t>
+              <a:t> — and a fresh-environment reproduction in one command (`make test-docker`) so "works on my machine" is testable.</a:t>
             </a:r>
           </a:p>
           <a:p>
             <a:pPr>
               <a:spcAft>
-                <a:spcPts val="1300"/>
+                <a:spcPts val="800"/>
               </a:spcAft>
             </a:pPr>
             <a:r>
-              <a:rPr b="1" sz="1700">
+              <a:rPr b="1" sz="1600">
                 <a:solidFill>
                   <a:srgbClr val="111111"/>
                 </a:solidFill>
                 <a:latin typeface="Calibri"/>
               </a:rPr>
-              <a:t>•  Two entry points on one engine</a:t>
-            </a:r>
-            <a:r>
-              <a:rPr sz="1700">
+              <a:t>•  Every fix is mutation-pinned</a:t>
+            </a:r>
+            <a:r>
+              <a:rPr sz="1600">
                 <a:solidFill>
                   <a:srgbClr val="333333"/>
                 </a:solidFill>
                 <a:latin typeface="Calibri"/>
               </a:rPr>
-              <a:t> — a chat coding agent and an autonomous ticket-to-PR pipeline of 19 agents.</a:t>
+              <a:t> — revert the fix and a named test must go red. Sweeps have found fixes that were pinned by nothing.</a:t>
             </a:r>
           </a:p>
           <a:p>
             <a:pPr>
               <a:spcAft>
-                <a:spcPts val="1300"/>
+                <a:spcPts val="800"/>
               </a:spcAft>
             </a:pPr>
             <a:r>
-              <a:rPr b="1" sz="1700">
+              <a:rPr b="1" sz="1600">
                 <a:solidFill>
                   <a:srgbClr val="111111"/>
                 </a:solidFill>
                 <a:latin typeface="Calibri"/>
               </a:rPr>
-              <a:t>•  Memory is a folder of markdown with typed edges</a:t>
-            </a:r>
-            <a:r>
-              <a:rPr sz="1700">
+              <a:t>•  New tests are run against the unfixed tree first</a:t>
+            </a:r>
+            <a:r>
+              <a:rPr sz="1600">
                 <a:solidFill>
                   <a:srgbClr val="333333"/>
                 </a:solidFill>
                 <a:latin typeface="Calibri"/>
               </a:rPr>
-              <a:t> — readable, diffable, revertible; vectors are optional, not load-bearing.</a:t>
+              <a:t> — a test that passes before the fix proves nothing.</a:t>
             </a:r>
           </a:p>
           <a:p>
             <a:pPr>
               <a:spcAft>
-                <a:spcPts val="1300"/>
+                <a:spcPts val="800"/>
               </a:spcAft>
             </a:pPr>
             <a:r>
-              <a:rPr sz="1700">
+              <a:rPr b="1" sz="1600">
+                <a:solidFill>
+                  <a:srgbClr val="111111"/>
+                </a:solidFill>
+                <a:latin typeface="Calibri"/>
+              </a:rPr>
+              <a:t>•  Real static analysis, not a hand-rolled meter</a:t>
+            </a:r>
+            <a:r>
+              <a:rPr sz="1600">
                 <a:solidFill>
                   <a:srgbClr val="333333"/>
                 </a:solidFill>
                 <a:latin typeface="Calibri"/>
               </a:rPr>
-              <a:t>•  Context is budgeted from the model's real window, folded once a day, and resumable rather than restartable.</a:t>
+              <a:t> — SonarQube is ground truth; a local complexity counter under-read one function by 38 points.</a:t>
             </a:r>
           </a:p>
           <a:p>
             <a:pPr>
               <a:spcAft>
-                <a:spcPts val="1300"/>
+                <a:spcPts val="800"/>
               </a:spcAft>
             </a:pPr>
             <a:r>
-              <a:rPr sz="1700">
+              <a:rPr b="1" sz="1600">
+                <a:solidFill>
+                  <a:srgbClr val="111111"/>
+                </a:solidFill>
+                <a:latin typeface="Calibri"/>
+              </a:rPr>
+              <a:t>•  Review rounds are repeated until they find nothing</a:t>
+            </a:r>
+            <a:r>
+              <a:rPr sz="1600">
                 <a:solidFill>
                   <a:srgbClr val="333333"/>
                 </a:solidFill>
                 <a:latin typeface="Calibri"/>
               </a:rPr>
-              <a:t>•  Long work runs in isolated git worktrees, fans out four ways, and extends its budget only when it is genuinely making progress.</a:t>
+              <a:t> — on several features every round found real defects inside the previous round's fixes.</a:t>
             </a:r>
           </a:p>
           <a:p>
             <a:pPr>
               <a:spcAft>
-                <a:spcPts val="1300"/>
+                <a:spcPts val="800"/>
               </a:spcAft>
             </a:pPr>
             <a:r>
-              <a:rPr sz="1700">
+              <a:rPr b="1" sz="1600">
+                <a:solidFill>
+                  <a:srgbClr val="111111"/>
+                </a:solidFill>
+                <a:latin typeface="Calibri"/>
+              </a:rPr>
+              <a:t>•  CI emits its own scan inputs</a:t>
+            </a:r>
+            <a:r>
+              <a:rPr sz="1600">
                 <a:solidFill>
                   <a:srgbClr val="333333"/>
                 </a:solidFill>
                 <a:latin typeface="Calibri"/>
               </a:rPr>
-              <a:t>•  Spend is capped by a sliding-window ceiling on every transport and shown in a live meter.</a:t>
-            </a:r>
-          </a:p>
-          <a:p>
-            <a:pPr>
-              <a:spcAft>
-                <a:spcPts val="1300"/>
-              </a:spcAft>
-            </a:pPr>
-            <a:r>
-              <a:rPr sz="1700">
-                <a:solidFill>
-                  <a:srgbClr val="333333"/>
-                </a:solidFill>
-                <a:latin typeface="Calibri"/>
-              </a:rPr>
-              <a:t>•  Autonomy is granted by blast radius; irreversible actions never run themselves.</a:t>
-            </a:r>
-          </a:p>
-          <a:p>
-            <a:pPr>
-              <a:spcAft>
-                <a:spcPts val="1300"/>
-              </a:spcAft>
-            </a:pPr>
-            <a:r>
-              <a:rPr b="1" sz="1700">
-                <a:solidFill>
-                  <a:srgbClr val="111111"/>
-                </a:solidFill>
-                <a:latin typeface="Calibri"/>
-              </a:rPr>
-              <a:t>•  A fleet shares durable knowledge through one admin hub, per group, with secrets filtered before anything is advertised</a:t>
-            </a:r>
-            <a:r>
-              <a:rPr sz="1700">
-                <a:solidFill>
-                  <a:srgbClr val="333333"/>
-                </a:solidFill>
-                <a:latin typeface="Calibri"/>
-              </a:rPr>
-              <a:t> — and per-person identity is the next step.</a:t>
-            </a:r>
-          </a:p>
-        </p:txBody>
-      </p:sp>
-      <p:sp>
-        <p:nvSpPr>
-          <p:cNvPr id="5" name="TextBox 4"/>
+              <a:t> — one build stage produces coverage, JUnit, pinned requirements and an SBOM for Sonar and Black Duck.</a:t>
+            </a:r>
+          </a:p>
+        </p:txBody>
+      </p:sp>
+      <p:sp>
+        <p:nvSpPr>
+          <p:cNvPr id="6" name="TextBox 5"/>
           <p:cNvSpPr txBox="1"/>
           <p:nvPr/>
         </p:nvSpPr>
@@ -8719,7 +9042,7 @@
       </p:sp>
       <p:sp>
         <p:nvSpPr>
-          <p:cNvPr id="6" name="TextBox 5"/>
+          <p:cNvPr id="7" name="TextBox 6"/>
           <p:cNvSpPr txBox="1"/>
           <p:nvPr/>
         </p:nvSpPr>
@@ -9067,6 +9390,383 @@
       <p:sp>
         <p:nvSpPr>
           <p:cNvPr id="7" name="TextBox 6"/>
+          <p:cNvSpPr txBox="1"/>
+          <p:nvPr/>
+        </p:nvSpPr>
+        <p:spPr>
+          <a:xfrm>
+            <a:off x="685800" y="6355080"/>
+            <a:ext cx="5486400" cy="320040"/>
+          </a:xfrm>
+          <a:prstGeom prst="rect">
+            <a:avLst/>
+          </a:prstGeom>
+          <a:noFill/>
+        </p:spPr>
+        <p:txBody>
+          <a:bodyPr wrap="none">
+            <a:spAutoFit/>
+          </a:bodyPr>
+          <a:lstStyle/>
+          <a:p>
+            <a:r>
+              <a:rPr sz="1000">
+                <a:solidFill>
+                  <a:srgbClr val="666666"/>
+                </a:solidFill>
+                <a:latin typeface="Calibri"/>
+              </a:rPr>
+              <a:t>AIForgeCrew</a:t>
+            </a:r>
+          </a:p>
+        </p:txBody>
+      </p:sp>
+    </p:spTree>
+  </p:cSld>
+  <p:clrMapOvr>
+    <a:masterClrMapping/>
+  </p:clrMapOvr>
+</p:sld>
+</file>
+
+<file path=ppt/slides/slide20.xml><?xml version="1.0" encoding="utf-8"?>
+<p:sld xmlns:a="http://schemas.openxmlformats.org/drawingml/2006/main" xmlns:p="http://schemas.openxmlformats.org/presentationml/2006/main" xmlns:r="http://schemas.openxmlformats.org/officeDocument/2006/relationships">
+  <p:cSld>
+    <p:spTree>
+      <p:nvGrpSpPr>
+        <p:cNvPr id="1" name=""/>
+        <p:cNvGrpSpPr/>
+        <p:nvPr/>
+      </p:nvGrpSpPr>
+      <p:grpSpPr/>
+      <p:sp>
+        <p:nvSpPr>
+          <p:cNvPr id="2" name="TextBox 1"/>
+          <p:cNvSpPr txBox="1"/>
+          <p:nvPr/>
+        </p:nvSpPr>
+        <p:spPr>
+          <a:xfrm>
+            <a:off x="685800" y="411480"/>
+            <a:ext cx="10817352" cy="640080"/>
+          </a:xfrm>
+          <a:prstGeom prst="rect">
+            <a:avLst/>
+          </a:prstGeom>
+          <a:noFill/>
+        </p:spPr>
+        <p:txBody>
+          <a:bodyPr wrap="none">
+            <a:spAutoFit/>
+          </a:bodyPr>
+          <a:lstStyle/>
+          <a:p>
+            <a:r>
+              <a:rPr sz="3000" b="1">
+                <a:solidFill>
+                  <a:srgbClr val="111111"/>
+                </a:solidFill>
+                <a:latin typeface="Calibri"/>
+              </a:rPr>
+              <a:t>In one slide</a:t>
+            </a:r>
+          </a:p>
+        </p:txBody>
+      </p:sp>
+      <p:sp>
+        <p:nvSpPr>
+          <p:cNvPr id="3" name="Rectangle 2"/>
+          <p:cNvSpPr/>
+          <p:nvPr/>
+        </p:nvSpPr>
+        <p:spPr>
+          <a:xfrm>
+            <a:off x="685800" y="1078992"/>
+            <a:ext cx="10817352" cy="17780"/>
+          </a:xfrm>
+          <a:prstGeom prst="rect">
+            <a:avLst/>
+          </a:prstGeom>
+          <a:solidFill>
+            <a:srgbClr val="1F4E79"/>
+          </a:solidFill>
+          <a:ln>
+            <a:noFill/>
+          </a:ln>
+          <a:effectLst/>
+        </p:spPr>
+        <p:style>
+          <a:lnRef idx="1">
+            <a:schemeClr val="accent1"/>
+          </a:lnRef>
+          <a:fillRef idx="3">
+            <a:schemeClr val="accent1"/>
+          </a:fillRef>
+          <a:effectRef idx="2">
+            <a:schemeClr val="accent1"/>
+          </a:effectRef>
+          <a:fontRef idx="minor">
+            <a:schemeClr val="lt1"/>
+          </a:fontRef>
+        </p:style>
+        <p:txBody>
+          <a:bodyPr rtlCol="0" anchor="ctr"/>
+          <a:lstStyle/>
+          <a:p>
+            <a:pPr algn="ctr"/>
+          </a:p>
+        </p:txBody>
+      </p:sp>
+      <p:sp>
+        <p:nvSpPr>
+          <p:cNvPr id="4" name="TextBox 3"/>
+          <p:cNvSpPr txBox="1"/>
+          <p:nvPr/>
+        </p:nvSpPr>
+        <p:spPr>
+          <a:xfrm>
+            <a:off x="685800" y="1298448"/>
+            <a:ext cx="10817352" cy="4754880"/>
+          </a:xfrm>
+          <a:prstGeom prst="rect">
+            <a:avLst/>
+          </a:prstGeom>
+          <a:noFill/>
+        </p:spPr>
+        <p:txBody>
+          <a:bodyPr wrap="square">
+            <a:spAutoFit/>
+          </a:bodyPr>
+          <a:lstStyle/>
+          <a:p>
+            <a:pPr>
+              <a:spcAft>
+                <a:spcPts val="1300"/>
+              </a:spcAft>
+            </a:pPr>
+            <a:r>
+              <a:rPr b="1" sz="1700">
+                <a:solidFill>
+                  <a:srgbClr val="111111"/>
+                </a:solidFill>
+                <a:latin typeface="Calibri"/>
+              </a:rPr>
+              <a:t>•  Built as one FastAPI process</a:t>
+            </a:r>
+            <a:r>
+              <a:rPr sz="1700">
+                <a:solidFill>
+                  <a:srgbClr val="333333"/>
+                </a:solidFill>
+                <a:latin typeface="Calibri"/>
+              </a:rPr>
+              <a:t> — no database to operate, no vendor lock, any OpenAI-compatible model.</a:t>
+            </a:r>
+          </a:p>
+          <a:p>
+            <a:pPr>
+              <a:spcAft>
+                <a:spcPts val="1300"/>
+              </a:spcAft>
+            </a:pPr>
+            <a:r>
+              <a:rPr b="1" sz="1700">
+                <a:solidFill>
+                  <a:srgbClr val="111111"/>
+                </a:solidFill>
+                <a:latin typeface="Calibri"/>
+              </a:rPr>
+              <a:t>•  Two entry points on one engine</a:t>
+            </a:r>
+            <a:r>
+              <a:rPr sz="1700">
+                <a:solidFill>
+                  <a:srgbClr val="333333"/>
+                </a:solidFill>
+                <a:latin typeface="Calibri"/>
+              </a:rPr>
+              <a:t> — a chat coding agent and an autonomous ticket-to-PR pipeline of 19 agents.</a:t>
+            </a:r>
+          </a:p>
+          <a:p>
+            <a:pPr>
+              <a:spcAft>
+                <a:spcPts val="1300"/>
+              </a:spcAft>
+            </a:pPr>
+            <a:r>
+              <a:rPr b="1" sz="1700">
+                <a:solidFill>
+                  <a:srgbClr val="111111"/>
+                </a:solidFill>
+                <a:latin typeface="Calibri"/>
+              </a:rPr>
+              <a:t>•  Memory is a folder of markdown with typed edges</a:t>
+            </a:r>
+            <a:r>
+              <a:rPr sz="1700">
+                <a:solidFill>
+                  <a:srgbClr val="333333"/>
+                </a:solidFill>
+                <a:latin typeface="Calibri"/>
+              </a:rPr>
+              <a:t> — readable, diffable, revertible; vectors are optional, not load-bearing.</a:t>
+            </a:r>
+          </a:p>
+          <a:p>
+            <a:pPr>
+              <a:spcAft>
+                <a:spcPts val="1300"/>
+              </a:spcAft>
+            </a:pPr>
+            <a:r>
+              <a:rPr sz="1700">
+                <a:solidFill>
+                  <a:srgbClr val="333333"/>
+                </a:solidFill>
+                <a:latin typeface="Calibri"/>
+              </a:rPr>
+              <a:t>•  Context is budgeted from the model's real window, folded once a day, and resumable rather than restartable.</a:t>
+            </a:r>
+          </a:p>
+          <a:p>
+            <a:pPr>
+              <a:spcAft>
+                <a:spcPts val="1300"/>
+              </a:spcAft>
+            </a:pPr>
+            <a:r>
+              <a:rPr sz="1700">
+                <a:solidFill>
+                  <a:srgbClr val="333333"/>
+                </a:solidFill>
+                <a:latin typeface="Calibri"/>
+              </a:rPr>
+              <a:t>•  Long work runs in isolated git worktrees, fans out four ways, and extends its budget only when it is genuinely making progress.</a:t>
+            </a:r>
+          </a:p>
+          <a:p>
+            <a:pPr>
+              <a:spcAft>
+                <a:spcPts val="1300"/>
+              </a:spcAft>
+            </a:pPr>
+            <a:r>
+              <a:rPr sz="1700">
+                <a:solidFill>
+                  <a:srgbClr val="333333"/>
+                </a:solidFill>
+                <a:latin typeface="Calibri"/>
+              </a:rPr>
+              <a:t>•  Spend is capped by a sliding-window ceiling on every transport and shown in a live meter.</a:t>
+            </a:r>
+          </a:p>
+          <a:p>
+            <a:pPr>
+              <a:spcAft>
+                <a:spcPts val="1300"/>
+              </a:spcAft>
+            </a:pPr>
+            <a:r>
+              <a:rPr sz="1700">
+                <a:solidFill>
+                  <a:srgbClr val="333333"/>
+                </a:solidFill>
+                <a:latin typeface="Calibri"/>
+              </a:rPr>
+              <a:t>•  Autonomy is granted by blast radius; irreversible actions never run themselves.</a:t>
+            </a:r>
+          </a:p>
+          <a:p>
+            <a:pPr>
+              <a:spcAft>
+                <a:spcPts val="1300"/>
+              </a:spcAft>
+            </a:pPr>
+            <a:r>
+              <a:rPr b="1" sz="1700">
+                <a:solidFill>
+                  <a:srgbClr val="111111"/>
+                </a:solidFill>
+                <a:latin typeface="Calibri"/>
+              </a:rPr>
+              <a:t>•  No telemetry, no vendor account, no hosted service</a:t>
+            </a:r>
+            <a:r>
+              <a:rPr sz="1700">
+                <a:solidFill>
+                  <a:srgbClr val="333333"/>
+                </a:solidFill>
+                <a:latin typeface="Calibri"/>
+              </a:rPr>
+              <a:t> — you own the model endpoint, the data and the machine.</a:t>
+            </a:r>
+          </a:p>
+          <a:p>
+            <a:pPr>
+              <a:spcAft>
+                <a:spcPts val="1300"/>
+              </a:spcAft>
+            </a:pPr>
+            <a:r>
+              <a:rPr b="1" sz="1700">
+                <a:solidFill>
+                  <a:srgbClr val="111111"/>
+                </a:solidFill>
+                <a:latin typeface="Calibri"/>
+              </a:rPr>
+              <a:t>•  A fleet shares durable knowledge through one admin hub, per group, with secrets filtered before anything is advertised</a:t>
+            </a:r>
+            <a:r>
+              <a:rPr sz="1700">
+                <a:solidFill>
+                  <a:srgbClr val="333333"/>
+                </a:solidFill>
+                <a:latin typeface="Calibri"/>
+              </a:rPr>
+              <a:t> — and per-person identity is the next step.</a:t>
+            </a:r>
+          </a:p>
+        </p:txBody>
+      </p:sp>
+      <p:sp>
+        <p:nvSpPr>
+          <p:cNvPr id="5" name="TextBox 4"/>
+          <p:cNvSpPr txBox="1"/>
+          <p:nvPr/>
+        </p:nvSpPr>
+        <p:spPr>
+          <a:xfrm>
+            <a:off x="11064240" y="6355080"/>
+            <a:ext cx="822960" cy="320040"/>
+          </a:xfrm>
+          <a:prstGeom prst="rect">
+            <a:avLst/>
+          </a:prstGeom>
+          <a:noFill/>
+        </p:spPr>
+        <p:txBody>
+          <a:bodyPr wrap="none">
+            <a:spAutoFit/>
+          </a:bodyPr>
+          <a:lstStyle/>
+          <a:p>
+            <a:pPr algn="r"/>
+            <a:r>
+              <a:rPr sz="1000">
+                <a:solidFill>
+                  <a:srgbClr val="666666"/>
+                </a:solidFill>
+                <a:latin typeface="Calibri"/>
+              </a:rPr>
+              <a:t>20</a:t>
+            </a:r>
+          </a:p>
+        </p:txBody>
+      </p:sp>
+      <p:sp>
+        <p:nvSpPr>
+          <p:cNvPr id="6" name="TextBox 5"/>
           <p:cNvSpPr txBox="1"/>
           <p:nvPr/>
         </p:nvSpPr>

</xml_diff>

<commit_message>
docs(deck): stop the security slides claiming more than the code does
Two overclaims caught reading the slides back against the source:

* "the workspace jail clamps paths" — it clamps the FILE TOOLS. run_command
  starts in the workspace and a shell can cd out of it, which the older
  security slide already said plainly and this one had quietly dropped.
* the per-agent allowlist row implied every role is filtered. The Doer is not:
  it builds its tools with no role, so its agents.yaml list documents intent.
  Said so on the slide, next to the number it qualifies.

A security slide that overstates is worse than no slide — the reader stops
checking.

Co-Authored-By: Claude Opus 5 (1M context) <noreply@anthropic.com>
Claude-Session: https://claude.ai/code/session_01RheJUKBtc2XzohZVsZkNuh
</commit_message>
<xml_diff>
--- a/docs/AIForgeCrew-Overview.pptx
+++ b/docs/AIForgeCrew-Overview.pptx
@@ -10897,6 +10897,22 @@
               <a:t>It never receives the schema · 9 of 19 roles get zero tools</a:t>
             </a:r>
           </a:p>
+          <a:p>
+            <a:pPr algn="l">
+              <a:spcAft>
+                <a:spcPts val="0"/>
+              </a:spcAft>
+            </a:pPr>
+            <a:r>
+              <a:rPr sz="1000" b="0">
+                <a:solidFill>
+                  <a:srgbClr val="6B6B6B"/>
+                </a:solidFill>
+                <a:latin typeface="Segoe UI"/>
+              </a:rPr>
+              <a:t>(the Doer runs unfiltered by design — its list documents intent)</a:t>
+            </a:r>
+          </a:p>
         </p:txBody>
       </p:sp>
       <p:sp>
@@ -13149,7 +13165,7 @@
                 </a:solidFill>
                 <a:latin typeface="Segoe UI"/>
               </a:rPr>
-              <a:t>The delete guard fires with approvals off · git add -A is refused · writes stay inside the ticket's scope · the workspace jail clamps paths · a REQUIRED sandbox refuses to fall back to the host, and the notebook kernel refuses with it.</a:t>
+              <a:t>The delete guard fires with approvals off · git add -A is refused · writes stay inside the ticket's scope · the workspace jail clamps the file tools (a shell can still cd out of it) · a REQUIRED sandbox refuses to fall back to the host, kernel included.</a:t>
             </a:r>
           </a:p>
         </p:txBody>

</xml_diff>